<commit_message>
Added day 4 study guides
</commit_message>
<xml_diff>
--- a/yocto_training_all_session_decks/session_decks/D3S6_SDK_devtool.pptx
+++ b/yocto_training_all_session_decks/session_decks/D3S6_SDK_devtool.pptx
@@ -5212,14 +5212,64 @@
           <a:lstStyle/>
           <a:p>
             <a:r>
-              <a:rPr sz="4400" b="1">
+              <a:rPr sz="4400" b="1" dirty="0">
                 <a:solidFill>
                   <a:srgbClr val="FFFFFF"/>
                 </a:solidFill>
                 <a:latin typeface="Calibri"/>
               </a:rPr>
-              <a:t>Developer Workflow — SDK, eSDK, devtool</a:t>
-            </a:r>
+              <a:t>Developer Workflow</a:t>
+            </a:r>
+            <a:br>
+              <a:rPr lang="en-IN" b="1" dirty="0">
+                <a:solidFill>
+                  <a:srgbClr val="FFFFFF"/>
+                </a:solidFill>
+                <a:latin typeface="Calibri"/>
+              </a:rPr>
+            </a:br>
+            <a:r>
+              <a:rPr sz="3200" b="1" dirty="0">
+                <a:solidFill>
+                  <a:srgbClr val="FFFFFF"/>
+                </a:solidFill>
+                <a:latin typeface="Calibri"/>
+              </a:rPr>
+              <a:t>SDK, </a:t>
+            </a:r>
+            <a:r>
+              <a:rPr sz="3200" b="1" dirty="0" err="1">
+                <a:solidFill>
+                  <a:srgbClr val="FFFFFF"/>
+                </a:solidFill>
+                <a:latin typeface="Calibri"/>
+              </a:rPr>
+              <a:t>eSDK</a:t>
+            </a:r>
+            <a:r>
+              <a:rPr sz="3200" b="1" dirty="0">
+                <a:solidFill>
+                  <a:srgbClr val="FFFFFF"/>
+                </a:solidFill>
+                <a:latin typeface="Calibri"/>
+              </a:rPr>
+              <a:t>, </a:t>
+            </a:r>
+            <a:r>
+              <a:rPr sz="3200" b="1" dirty="0" err="1">
+                <a:solidFill>
+                  <a:srgbClr val="FFFFFF"/>
+                </a:solidFill>
+                <a:latin typeface="Calibri"/>
+              </a:rPr>
+              <a:t>devtool</a:t>
+            </a:r>
+            <a:endParaRPr sz="4400" b="1" dirty="0">
+              <a:solidFill>
+                <a:srgbClr val="FFFFFF"/>
+              </a:solidFill>
+              <a:latin typeface="Calibri"/>
+            </a:endParaRPr>
           </a:p>
         </p:txBody>
       </p:sp>

</xml_diff>